<commit_message>
Incorporate reviewed advisory principles into talk track and notes
- Slide 1: name the three decisions inside the first minute
- Slide 10: name fair process (engagement, explanation, expectation clarity)
- Slide 13: set walk-aways before spend so sunk cost has no vote
- Q&A: add Theme H (Q85-Q88): weights, framework, evidence vs judgment, sunk cost
- Add rule for citing outside authorities and a review of the ten principles
- Timing recomputed (24.8 min); cue cards updated

Co-Authored-By: Claude <noreply@anthropic.com>
Claude-Session: https://claude.ai/code/session_01Doo6tr47JMFKLP8DAfqjkf
</commit_message>
<xml_diff>
--- a/deck/CFO_CoS_deck_v10_presenter.pptx
+++ b/deck/CFO_CoS_deck_v10_presenter.pptx
@@ -832,7 +832,7 @@
           <a:lstStyle/>
           <a:p>
             <a:r>
-              <a:t>TIME 1.3 min | PACE steady, warm | TONE calm, composed | Say 'we', not 'I'</a:t>
+              <a:t>TIME 1.5 min | PACE steady, warm | TONE calm, composed | Say 'we', not 'I'</a:t>
             </a:r>
           </a:p>
           <a:p>
@@ -867,12 +867,17 @@
           </a:p>
           <a:p>
             <a:r>
+              <a:t>- NAME THE ASK NOW: by the end we'll ask for three decisions: the cap, the Board calendar, the HQ gates.</a:t>
+            </a:r>
+          </a:p>
+          <a:p>
+            <a:r>
               <a:t>STRESS: sixty days in; twenty-five million; four weeks; growth levers; without losing the speed</a:t>
             </a:r>
           </a:p>
           <a:p>
             <a:r>
-              <a:t>PAUSE: after 'cap'; after 'four weeks'; before 'One thread'</a:t>
+              <a:t>PAUSE: after 'cap'; after 'four weeks'; before 'One thread'; after 'three decisions'</a:t>
             </a:r>
           </a:p>
           <a:p>
@@ -957,7 +962,7 @@
           <a:lstStyle/>
           <a:p>
             <a:r>
-              <a:t>TIME 1.8 min | PACE steady; slower and lower on the story | TONE personal, respectful, humble | Say 'we', not 'I'</a:t>
+              <a:t>TIME 1.9 min | PACE steady; slower and lower on the story | TONE personal, respectful, humble | Say 'we', not 'I'</a:t>
             </a:r>
           </a:p>
           <a:p>
@@ -987,6 +992,11 @@
           </a:p>
           <a:p>
             <a:r>
+              <a:t>- Why it works without authority: public rules, private talks, joint sign-off = fair process (Kim &amp; Mauborgne): engagement, explanation, clear expectations. Say 'the argument is', never 'proves'.</a:t>
+            </a:r>
+          </a:p>
+          <a:p>
+            <a:r>
               <a:t>- Optional pattern line (your own, from v10 notes): 'I've seen fast, agile companies like Itau BBA get slowed down by increasing committees and many cooks in the kitchen. Consensus everywhere all the time is not a reasonable expectation; disagree and commit is a good, mature outcome.' Tip: describe the pattern, not the institution.</a:t>
             </a:r>
           </a:p>
@@ -1002,7 +1012,7 @@
           </a:p>
           <a:p>
             <a:r>
-              <a:t>IF ASKED: Q56 GM won't accept | Q57 leverage without authority | Q55 governance slows fast companies | Q59 no commitment.</a:t>
+              <a:t>IF ASKED: Q56 GM won't accept | Q57 leverage without authority | Q55 governance slows fast companies | Q59 no commitment | Q86 framework behind it.</a:t>
             </a:r>
           </a:p>
           <a:p>
@@ -1322,7 +1332,7 @@
           <a:lstStyle/>
           <a:p>
             <a:r>
-              <a:t>TIME 1.4 min | PACE SLOW on the four questions and the walk-away | TONE crisp, firm | Say 'we', not 'I'</a:t>
+              <a:t>TIME 1.6 min | PACE SLOW on the four questions and the walk-away | TONE crisp, firm | Say 'we', not 'I'</a:t>
             </a:r>
           </a:p>
           <a:p>
@@ -1362,6 +1372,11 @@
           </a:p>
           <a:p>
             <a:r>
+              <a:t>- Walk-aways are set BEFORE we spend anything: sunk cost doesn't get a vote.</a:t>
+            </a:r>
+          </a:p>
+          <a:p>
+            <a:r>
               <a:t>- We are the project office; the MTeam decides.</a:t>
             </a:r>
           </a:p>
@@ -1377,7 +1392,7 @@
           </a:p>
           <a:p>
             <a:r>
-              <a:t>IF ASKED: Q64 grant walk-away | Q66 120 days realistic? | Q67 residence moves for both | Q73 lease before incentive.</a:t>
+              <a:t>IF ASKED: Q64 grant walk-away | Q66 120 days realistic? | Q67 residence moves for both | Q73 lease before incentive | Q88 sunk cost.</a:t>
             </a:r>
           </a:p>
           <a:p>
@@ -1797,7 +1812,7 @@
           </a:p>
           <a:p>
             <a:r>
-              <a:t>Q: Q6 | Q2 | Q21 | Q35.</a:t>
+              <a:t>Q: Q6 | Q2 | Q21 | Q35 | Q87 (what is evidence vs judgment).</a:t>
             </a:r>
           </a:p>
         </p:txBody>
@@ -1967,7 +1982,7 @@
           </a:p>
           <a:p>
             <a:r>
-              <a:t>Q: Q37 | Q32 | Q33 | Q68.</a:t>
+              <a:t>Q: Q37 | Q32 | Q33 | Q68 | Q87. Outside sources (McKinsey, Deloitte, Gartner) are CONTEXT: don't say 'studies show'.</a:t>
             </a:r>
           </a:p>
         </p:txBody>
@@ -2915,7 +2930,7 @@
           </a:p>
           <a:p>
             <a:r>
-              <a:t>IF ASKED: Q26 rewards storytellers? | Q27 sandbagging | Q30 mandatory spend over the cap.</a:t>
+              <a:t>IF ASKED: Q26 rewards storytellers? | Q27 sandbagging | Q30 mandatory spend over the cap | Q85 why these weights (judgment; test rank sensitivity).</a:t>
             </a:r>
           </a:p>
           <a:p>

</xml_diff>

<commit_message>
Add Wall Street and market context to talk track, notes and Q&A
- Slide 5 and 9 scripts: one public-guide callout, Nu's first Investor Day
- Q&A Theme I (Q89-Q93): Street sentiment, Investor Day, Monzo episode, credit bear case, stock/Q3 guardrail
- Edit Q38 and Q83; add landmines and content traps
- Section 9: dated public-source snapshot, corrections to a pasted summary, links to the case
- Timing recomputed (25.0 min); cue cards for slides 5, 7, 9 updated

Co-Authored-By: Claude <noreply@anthropic.com>
Claude-Session: https://claude.ai/code/session_01Doo6tr47JMFKLP8DAfqjkf
</commit_message>
<xml_diff>
--- a/deck/CFO_CoS_deck_v10_presenter.pptx
+++ b/deck/CFO_CoS_deck_v10_presenter.pptx
@@ -2772,7 +2772,7 @@
           <a:lstStyle/>
           <a:p>
             <a:r>
-              <a:t>TIME 2.2 min | PACE SLOW on the scale numbers, then steady | TONE plain, calm, no drama | Say 'we', not 'I'</a:t>
+              <a:t>TIME 2.4 min | PACE SLOW on the scale numbers, then steady | TONE plain, calm, no drama | Say 'we', not 'I'</a:t>
             </a:r>
           </a:p>
           <a:p>
@@ -2797,6 +2797,11 @@
           </a:p>
           <a:p>
             <a:r>
+              <a:t>- CALLOUT: that guide is public, so how we spend inside it is part of the equity story. (No price targets or ratings.)</a:t>
+            </a:r>
+          </a:p>
+          <a:p>
+            <a:r>
               <a:t>- Broken today: asks are one number, no shared format.</a:t>
             </a:r>
           </a:p>
@@ -2827,7 +2832,7 @@
           </a:p>
           <a:p>
             <a:r>
-              <a:t>IF ASKED: Q31 why bother | Q32 why ER rose | Q33 CTS is not margin | Q34 where low-and-grow breaks | Q25 equal cut.</a:t>
+              <a:t>IF ASKED: Q31 why bother | Q32 why ER rose | Q33 CTS is not margin | Q34 where low-and-grow breaks | Q25 equal cut | Q89 what the Street is watching (public sources only).</a:t>
             </a:r>
           </a:p>
           <a:p>
@@ -3023,6 +3028,11 @@
           </a:p>
           <a:p>
             <a:r>
+              <a:t>- If a bear asks: the checkpoint needs credit on plan and the efficiency guide. If credit normalizes, the $35M stays closed (Q92).</a:t>
+            </a:r>
+          </a:p>
+          <a:p>
+            <a:r>
               <a:t>- 70/30: mature cohorts ~$31/month vs $17.1 group.</a:t>
             </a:r>
           </a:p>
@@ -3043,7 +3053,7 @@
           </a:p>
           <a:p>
             <a:r>
-              <a:t>IF ASKED: Q21 | Q22 reserve | Q23-24 70/30 | Q27-29 checkpoint | Q41 Q4 wording.</a:t>
+              <a:t>IF ASKED: Q21 | Q22 reserve | Q23-24 70/30 | Q27-29 checkpoint | Q41 Q4 wording | Q92 bears say Q2 was flattered by provisioning.</a:t>
             </a:r>
           </a:p>
           <a:p>
@@ -3239,7 +3249,7 @@
           </a:p>
           <a:p>
             <a:r>
-              <a:t>- Board assumed Tue 17 Nov; Q3 results 12 Nov; Investor Day 8 Dec.</a:t>
+              <a:t>- Board assumed Tue 17 Nov; Q3 results 12 Nov; Nu's FIRST Investor Day 8 Dec (Nu says: strategy, growth, value drivers; no targets confirmed).</a:t>
             </a:r>
           </a:p>
           <a:p>
@@ -3264,7 +3274,7 @@
           </a:p>
           <a:p>
             <a:r>
-              <a:t>IF ASKED: Q42 why late | Q43 why 7 days | Q44 weekends | Q45 Q3 timing | Q46 disagree at the lock | Q54 AI drafting.</a:t>
+              <a:t>IF ASKED: Q42 why late | Q43 why 7 days | Q44 weekends | Q45 Q3 timing | Q46 disagree at the lock | Q54 AI drafting | Q90 what to commit at Investor Day | Q93 don't forecast Q3.</a:t>
             </a:r>
           </a:p>
           <a:p>

</xml_diff>

<commit_message>
Revise script, notes and Q&A after second playbook review
- Slide 1: why-now anchor (Board about three weeks before first Investor Day)
- Slide 5: all three envelope denominators, name who pays for the speed trade-off
- Slide 15: state the CFO makes the funding call; end on the ask
- Q&A: add Theme J (Q94 decision rights, Q95 first-cycle realism)
- Section 8.2 records what was adopted and what was rejected; timing recomputed (25.3 min)

Co-Authored-By: Claude <noreply@anthropic.com>
Claude-Session: https://claude.ai/code/session_01Doo6tr47JMFKLP8DAfqjkf
</commit_message>
<xml_diff>
--- a/deck/CFO_CoS_deck_v10_presenter.pptx
+++ b/deck/CFO_CoS_deck_v10_presenter.pptx
@@ -832,7 +832,7 @@
           <a:lstStyle/>
           <a:p>
             <a:r>
-              <a:t>TIME 1.5 min | PACE steady, warm | TONE calm, composed | Say 'we', not 'I'</a:t>
+              <a:t>TIME 1.6 min | PACE steady, warm | TONE calm, composed | Say 'we', not 'I'</a:t>
             </a:r>
           </a:p>
           <a:p>
@@ -852,7 +852,7 @@
           </a:p>
           <a:p>
             <a:r>
-              <a:t>- A Board in 4 weeks, two executives who see capital differently.</a:t>
+              <a:t>- A Board in 4 weeks (about 3 weeks before Nu's first Investor Day), two executives who see capital differently.</a:t>
             </a:r>
           </a:p>
           <a:p>
@@ -1597,7 +1597,7 @@
           <a:lstStyle/>
           <a:p>
             <a:r>
-              <a:t>TIME 1.4 min | PACE steady; SLOW on the ask | TONE firm, brief, grateful | Say 'we', not 'I'</a:t>
+              <a:t>TIME 1.5 min | PACE steady; SLOW on the ask | TONE firm, brief, grateful | Say 'we', not 'I'</a:t>
             </a:r>
           </a:p>
           <a:p>
@@ -1617,22 +1617,22 @@
           </a:p>
           <a:p>
             <a:r>
+              <a:t>- The GLOBAL CFO makes the funding call; the team never does.</a:t>
+            </a:r>
+          </a:p>
+          <a:p>
+            <a:r>
               <a:t>- Quarterly with the CFO: KEEP IT, FIX IT, OR DROP IT.</a:t>
             </a:r>
           </a:p>
           <a:p>
             <a:r>
-              <a:t>- THE ASK (full pause after each): the $25M cap in two releases; the Board calendar; the HQ gates.</a:t>
-            </a:r>
-          </a:p>
-          <a:p>
-            <a:r>
-              <a:t>- Report back in 90 days.</a:t>
-            </a:r>
-          </a:p>
-          <a:p>
-            <a:r>
-              <a:t>- Close: finance and governance as growth levers, with the rigor scale needs and the speed Nu already has.</a:t>
+              <a:t>- Thread first: finance and governance as growth levers, with the rigor scale needs and the speed Nu already has.</a:t>
+            </a:r>
+          </a:p>
+          <a:p>
+            <a:r>
+              <a:t>- THEN THE ASK, LAST (full pause after each): the $25M cap in two releases; the Board calendar; the HQ gates. Report back in 90 days. Nothing after it but 'Happy to take questions.'</a:t>
             </a:r>
           </a:p>
           <a:p>
@@ -1647,7 +1647,7 @@
           </a:p>
           <a:p>
             <a:r>
-              <a:t>IF ASKED: Q1 one more layer | Q51 is the Board better off | Q80 what success looks like at 90 days.</a:t>
+              <a:t>IF ASKED: Q1 one more layer | Q51 is the Board better off | Q80 what success looks like at 90 days | Q94 who decides what.</a:t>
             </a:r>
           </a:p>
           <a:p>
@@ -2772,7 +2772,7 @@
           <a:lstStyle/>
           <a:p>
             <a:r>
-              <a:t>TIME 2.4 min | PACE SLOW on the scale numbers, then steady | TONE plain, calm, no drama | Say 'we', not 'I'</a:t>
+              <a:t>TIME 2.6 min | PACE SLOW on the scale numbers, then steady | TONE plain, calm, no drama | Say 'we', not 'I'</a:t>
             </a:r>
           </a:p>
           <a:p>
@@ -2787,7 +2787,7 @@
           </a:p>
           <a:p>
             <a:r>
-              <a:t>- ~15 bps of revenue; ~0.2 pt of efficiency ratio. Say it calmly, then stop.</a:t>
+              <a:t>- ~15 bps of revenue; ~1% of opex; ~0.2 pt of efficiency ratio. One number per sentence. Say it calmly, then stop.</a:t>
             </a:r>
           </a:p>
           <a:p>
@@ -2807,7 +2807,7 @@
           </a:p>
           <a:p>
             <a:r>
-              <a:t>- Equal cut teaches padding; core-first starves new bets; staged release costs speed.</a:t>
+              <a:t>- Equal cut teaches padding; core-first starves new bets; staged release: the PRICE IS SPEED and it asks GMs for a proper case up front.</a:t>
             </a:r>
           </a:p>
           <a:p>
@@ -3161,7 +3161,7 @@
           </a:p>
           <a:p>
             <a:r>
-              <a:t>IF ASKED: Q49 turf with Chair/Secretary | Q58 GM goes to the CEO.</a:t>
+              <a:t>IF ASKED: Q49 turf with Chair/Secretary | Q58 GM goes to the CEO | Q94 who decides what.</a:t>
             </a:r>
           </a:p>
           <a:p>
@@ -3274,7 +3274,7 @@
           </a:p>
           <a:p>
             <a:r>
-              <a:t>IF ASKED: Q42 why late | Q43 why 7 days | Q44 weekends | Q45 Q3 timing | Q46 disagree at the lock | Q54 AI drafting | Q90 what to commit at Investor Day | Q93 don't forecast Q3.</a:t>
+              <a:t>IF ASKED: Q42 why late | Q43 why 7 days | Q44 weekends | Q45 Q3 timing | Q46 disagree at the lock | Q54 AI drafting | Q90 what to commit at Investor Day | Q93 don't forecast Q3 | Q95 can this work for this Board (first cycle is a pilot).</a:t>
             </a:r>
           </a:p>
           <a:p>

</xml_diff>